<commit_message>
small updates on presentation
</commit_message>
<xml_diff>
--- a/presentation/presentation_youtube_qa_chatbot.pptx
+++ b/presentation/presentation_youtube_qa_chatbot.pptx
@@ -1836,15 +1836,75 @@
               <a:buNone/>
             </a:pPr>
             <a:r>
+              <a:rPr lang="de-DE" altLang="en-US" sz="4400" b="1" dirty="0">
+                <a:solidFill>
+                  <a:srgbClr val="1E293B"/>
+                </a:solidFill>
+                <a:latin typeface="Calibri" panose="020F0502020204030204" pitchFamily="34" charset="0"/>
+                <a:ea typeface="Calibri" panose="020F0502020204030204" pitchFamily="34" charset="-122"/>
+                <a:cs typeface="Calibri" panose="020F0502020204030204" pitchFamily="34" charset="-120"/>
+              </a:rPr>
+              <a:t>StocksTalk.AI</a:t>
+            </a:r>
+            <a:endParaRPr lang="en-US" sz="4400" dirty="0"/>
+          </a:p>
+        </p:txBody>
+      </p:sp>
+      <p:sp>
+        <p:nvSpPr>
+          <p:cNvPr id="8" name="Text 6"/>
+          <p:cNvSpPr/>
+          <p:nvPr/>
+        </p:nvSpPr>
+        <p:spPr>
+          <a:xfrm>
+            <a:off x="457200" y="3070225"/>
+            <a:ext cx="7315200" cy="816559"/>
+          </a:xfrm>
+          <a:prstGeom prst="rect">
+            <a:avLst/>
+          </a:prstGeom>
+          <a:noFill/>
+        </p:spPr>
+        <p:txBody>
+          <a:bodyPr wrap="square" lIns="0" tIns="0" rIns="0" bIns="0" rtlCol="0" anchor="ctr"/>
+          <a:lstStyle/>
+          <a:p>
+            <a:pPr marL="0" indent="0">
+              <a:buNone/>
+            </a:pPr>
+            <a:r>
+              <a:rPr lang="en-US" altLang="en-US" sz="4400" b="1" dirty="0">
+                <a:solidFill>
+                  <a:srgbClr val="0F766E"/>
+                </a:solidFill>
+                <a:latin typeface="Calibri" panose="020F0502020204030204" pitchFamily="34" charset="0"/>
+                <a:ea typeface="Calibri" panose="020F0502020204030204" pitchFamily="34" charset="-122"/>
+                <a:cs typeface="Calibri" panose="020F0502020204030204" pitchFamily="34" charset="-120"/>
+              </a:rPr>
+              <a:t>Multimodal AI ChatBot</a:t>
+            </a:r>
+            <a:r>
+              <a:rPr lang="de-DE" altLang="en-US" sz="4400" b="1" dirty="0">
+                <a:solidFill>
+                  <a:srgbClr val="0F766E"/>
+                </a:solidFill>
+                <a:latin typeface="Calibri" panose="020F0502020204030204" pitchFamily="34" charset="0"/>
+                <a:ea typeface="Calibri" panose="020F0502020204030204" pitchFamily="34" charset="-122"/>
+                <a:cs typeface="Calibri" panose="020F0502020204030204" pitchFamily="34" charset="-120"/>
+              </a:rPr>
+              <a:t> f</a:t>
+            </a:r>
+            <a:r>
               <a:rPr lang="en-US" sz="4400" b="1" dirty="0">
                 <a:solidFill>
-                  <a:srgbClr val="1E293B"/>
-                </a:solidFill>
-                <a:latin typeface="Calibri" panose="020F0502020204030204" pitchFamily="34" charset="0"/>
-                <a:ea typeface="Calibri" panose="020F0502020204030204" pitchFamily="34" charset="-122"/>
-                <a:cs typeface="Calibri" panose="020F0502020204030204" pitchFamily="34" charset="-120"/>
-              </a:rPr>
-              <a:t>Multimodal AI ChatBot</a:t>
+                  <a:srgbClr val="0F766E"/>
+                </a:solidFill>
+                <a:latin typeface="Calibri" panose="020F0502020204030204" pitchFamily="34" charset="0"/>
+                <a:ea typeface="Calibri" panose="020F0502020204030204" pitchFamily="34" charset="-122"/>
+                <a:cs typeface="Calibri" panose="020F0502020204030204" pitchFamily="34" charset="-120"/>
+              </a:rPr>
+              <a:t>or YouTube Video QA</a:t>
             </a:r>
             <a:endParaRPr lang="en-US" sz="4400" dirty="0"/>
           </a:p>
@@ -1852,51 +1912,13 @@
       </p:sp>
       <p:sp>
         <p:nvSpPr>
-          <p:cNvPr id="8" name="Text 6"/>
-          <p:cNvSpPr/>
-          <p:nvPr/>
-        </p:nvSpPr>
-        <p:spPr>
-          <a:xfrm>
-            <a:off x="457200" y="2514600"/>
-            <a:ext cx="7315200" cy="868680"/>
-          </a:xfrm>
-          <a:prstGeom prst="rect">
-            <a:avLst/>
-          </a:prstGeom>
-          <a:noFill/>
-        </p:spPr>
-        <p:txBody>
-          <a:bodyPr wrap="square" lIns="0" tIns="0" rIns="0" bIns="0" rtlCol="0" anchor="ctr"/>
-          <a:lstStyle/>
-          <a:p>
-            <a:pPr marL="0" indent="0">
-              <a:buNone/>
-            </a:pPr>
-            <a:r>
-              <a:rPr lang="en-US" sz="4400" b="1" dirty="0">
-                <a:solidFill>
-                  <a:srgbClr val="0F766E"/>
-                </a:solidFill>
-                <a:latin typeface="Calibri" panose="020F0502020204030204" pitchFamily="34" charset="0"/>
-                <a:ea typeface="Calibri" panose="020F0502020204030204" pitchFamily="34" charset="-122"/>
-                <a:cs typeface="Calibri" panose="020F0502020204030204" pitchFamily="34" charset="-120"/>
-              </a:rPr>
-              <a:t>for YouTube Video QA</a:t>
-            </a:r>
-            <a:endParaRPr lang="en-US" sz="4400" dirty="0"/>
-          </a:p>
-        </p:txBody>
-      </p:sp>
-      <p:sp>
-        <p:nvSpPr>
           <p:cNvPr id="9" name="Text 7"/>
           <p:cNvSpPr/>
           <p:nvPr/>
         </p:nvSpPr>
         <p:spPr>
           <a:xfrm>
-            <a:off x="457200" y="3520440"/>
+            <a:off x="457200" y="4128770"/>
             <a:ext cx="7772400" cy="365760"/>
           </a:xfrm>
           <a:prstGeom prst="rect">
@@ -2257,6 +2279,17 @@
               <a:buNone/>
             </a:pPr>
             <a:r>
+              <a:rPr lang="de-DE" altLang="en-US" sz="1500" b="1" i="1" dirty="0">
+                <a:solidFill>
+                  <a:srgbClr val="1E293B"/>
+                </a:solidFill>
+                <a:latin typeface="Calibri" panose="020F0502020204030204" pitchFamily="34" charset="0"/>
+                <a:ea typeface="Calibri" panose="020F0502020204030204" pitchFamily="34" charset="-122"/>
+                <a:cs typeface="Calibri" panose="020F0502020204030204" pitchFamily="34" charset="-120"/>
+              </a:rPr>
+              <a:t>The aim is to ask</a:t>
+            </a:r>
+            <a:r>
               <a:rPr lang="en-US" sz="1500" b="1" i="1" dirty="0">
                 <a:solidFill>
                   <a:srgbClr val="1E293B"/>
@@ -2265,7 +2298,29 @@
                 <a:ea typeface="Calibri" panose="020F0502020204030204" pitchFamily="34" charset="-122"/>
                 <a:cs typeface="Calibri" panose="020F0502020204030204" pitchFamily="34" charset="-120"/>
               </a:rPr>
-              <a:t>What if you could ask any question about a YouTube channel</a:t>
+              <a:t> any question about a YouTube </a:t>
+            </a:r>
+            <a:r>
+              <a:rPr lang="de-DE" altLang="en-US" sz="1500" b="1" i="1" dirty="0">
+                <a:solidFill>
+                  <a:srgbClr val="1E293B"/>
+                </a:solidFill>
+                <a:latin typeface="Calibri" panose="020F0502020204030204" pitchFamily="34" charset="0"/>
+                <a:ea typeface="Calibri" panose="020F0502020204030204" pitchFamily="34" charset="-122"/>
+                <a:cs typeface="Calibri" panose="020F0502020204030204" pitchFamily="34" charset="-120"/>
+              </a:rPr>
+              <a:t>financial </a:t>
+            </a:r>
+            <a:r>
+              <a:rPr lang="en-US" sz="1500" b="1" i="1" dirty="0">
+                <a:solidFill>
+                  <a:srgbClr val="1E293B"/>
+                </a:solidFill>
+                <a:latin typeface="Calibri" panose="020F0502020204030204" pitchFamily="34" charset="0"/>
+                <a:ea typeface="Calibri" panose="020F0502020204030204" pitchFamily="34" charset="-122"/>
+                <a:cs typeface="Calibri" panose="020F0502020204030204" pitchFamily="34" charset="-120"/>
+              </a:rPr>
+              <a:t>channel</a:t>
             </a:r>
             <a:endParaRPr lang="en-US" sz="1500" dirty="0"/>
           </a:p>
@@ -2282,9 +2337,27 @@
                 <a:ea typeface="Calibri" panose="020F0502020204030204" pitchFamily="34" charset="-122"/>
                 <a:cs typeface="Calibri" panose="020F0502020204030204" pitchFamily="34" charset="-120"/>
               </a:rPr>
-              <a:t>and get an instant, sourced answer — with exact video timestamps?</a:t>
-            </a:r>
-            <a:endParaRPr lang="en-US" sz="1500" dirty="0"/>
+              <a:t>and get an instant, sourced answer — with exact video timestamps</a:t>
+            </a:r>
+            <a:r>
+              <a:rPr lang="de-DE" altLang="en-US" sz="1500" b="1" i="1" dirty="0">
+                <a:solidFill>
+                  <a:srgbClr val="1E293B"/>
+                </a:solidFill>
+                <a:latin typeface="Calibri" panose="020F0502020204030204" pitchFamily="34" charset="0"/>
+                <a:ea typeface="Calibri" panose="020F0502020204030204" pitchFamily="34" charset="-122"/>
+                <a:cs typeface="Calibri" panose="020F0502020204030204" pitchFamily="34" charset="-120"/>
+              </a:rPr>
+              <a:t>.</a:t>
+            </a:r>
+            <a:endParaRPr lang="de-DE" altLang="en-US" sz="1500" b="1" i="1" dirty="0">
+              <a:solidFill>
+                <a:srgbClr val="1E293B"/>
+              </a:solidFill>
+              <a:latin typeface="Calibri" panose="020F0502020204030204" pitchFamily="34" charset="0"/>
+              <a:ea typeface="Calibri" panose="020F0502020204030204" pitchFamily="34" charset="-122"/>
+              <a:cs typeface="Calibri" panose="020F0502020204030204" pitchFamily="34" charset="-120"/>
+            </a:endParaRPr>
           </a:p>
         </p:txBody>
       </p:sp>
@@ -5253,10 +5326,35 @@
                 <a:latin typeface="Calibri" panose="020F0502020204030204" pitchFamily="34" charset="0"/>
                 <a:ea typeface="Calibri" panose="020F0502020204030204" pitchFamily="34" charset="-122"/>
                 <a:cs typeface="Calibri" panose="020F0502020204030204" pitchFamily="34" charset="-120"/>
+                <a:sym typeface="+mn-ea"/>
               </a:rPr>
               <a:t>Serverless AWS us-east-1</a:t>
             </a:r>
             <a:endParaRPr lang="en-US" sz="1000" dirty="0"/>
+          </a:p>
+          <a:p>
+            <a:pPr marL="0" indent="0">
+              <a:buNone/>
+            </a:pPr>
+            <a:r>
+              <a:rPr lang="de-DE" altLang="en-US" sz="1000" dirty="0">
+                <a:solidFill>
+                  <a:srgbClr val="334155"/>
+                </a:solidFill>
+                <a:latin typeface="Calibri" panose="020F0502020204030204" pitchFamily="34" charset="0"/>
+                <a:ea typeface="Calibri" panose="020F0502020204030204" pitchFamily="34" charset="-122"/>
+                <a:cs typeface="Calibri" panose="020F0502020204030204" pitchFamily="34" charset="-120"/>
+              </a:rPr>
+              <a:t>Record count: 808</a:t>
+            </a:r>
+            <a:endParaRPr lang="en-US" sz="1000" dirty="0">
+              <a:solidFill>
+                <a:srgbClr val="334155"/>
+              </a:solidFill>
+              <a:latin typeface="Calibri" panose="020F0502020204030204" pitchFamily="34" charset="0"/>
+              <a:ea typeface="Calibri" panose="020F0502020204030204" pitchFamily="34" charset="-122"/>
+              <a:cs typeface="Calibri" panose="020F0502020204030204" pitchFamily="34" charset="-120"/>
+            </a:endParaRPr>
           </a:p>
           <a:p>
             <a:pPr marL="0" indent="0">
@@ -5814,9 +5912,27 @@
                 <a:ea typeface="Calibri" panose="020F0502020204030204" pitchFamily="34" charset="-122"/>
                 <a:cs typeface="Calibri" panose="020F0502020204030204" pitchFamily="34" charset="-120"/>
               </a:rPr>
-              <a:t>Max iter.</a:t>
-            </a:r>
-            <a:endParaRPr lang="en-US" sz="1050" dirty="0"/>
+              <a:t>Max iter</a:t>
+            </a:r>
+            <a:r>
+              <a:rPr lang="de-DE" altLang="en-US" sz="1050" b="1" dirty="0">
+                <a:solidFill>
+                  <a:srgbClr val="0F766E"/>
+                </a:solidFill>
+                <a:latin typeface="Calibri" panose="020F0502020204030204" pitchFamily="34" charset="0"/>
+                <a:ea typeface="Calibri" panose="020F0502020204030204" pitchFamily="34" charset="-122"/>
+                <a:cs typeface="Calibri" panose="020F0502020204030204" pitchFamily="34" charset="-120"/>
+              </a:rPr>
+              <a:t>ations</a:t>
+            </a:r>
+            <a:endParaRPr lang="de-DE" altLang="en-US" sz="1050" b="1" dirty="0">
+              <a:solidFill>
+                <a:srgbClr val="0F766E"/>
+              </a:solidFill>
+              <a:latin typeface="Calibri" panose="020F0502020204030204" pitchFamily="34" charset="0"/>
+              <a:ea typeface="Calibri" panose="020F0502020204030204" pitchFamily="34" charset="-122"/>
+              <a:cs typeface="Calibri" panose="020F0502020204030204" pitchFamily="34" charset="-120"/>
+            </a:endParaRPr>
           </a:p>
         </p:txBody>
       </p:sp>
@@ -5891,7 +6007,7 @@
         </p:nvSpPr>
         <p:spPr>
           <a:xfrm>
-            <a:off x="594360" y="2962656"/>
+            <a:off x="594360" y="2998851"/>
             <a:ext cx="1234440" cy="292608"/>
           </a:xfrm>
           <a:prstGeom prst="rect">
@@ -5915,9 +6031,49 @@
                 <a:ea typeface="Calibri" panose="020F0502020204030204" pitchFamily="34" charset="-122"/>
                 <a:cs typeface="Calibri" panose="020F0502020204030204" pitchFamily="34" charset="-120"/>
               </a:rPr>
-              <a:t>Error hdl</a:t>
-            </a:r>
-            <a:endParaRPr lang="en-US" sz="1050" dirty="0"/>
+              <a:t>Error h</a:t>
+            </a:r>
+            <a:r>
+              <a:rPr lang="de-DE" altLang="en-US" sz="1050" b="1" dirty="0">
+                <a:solidFill>
+                  <a:srgbClr val="0F766E"/>
+                </a:solidFill>
+                <a:latin typeface="Calibri" panose="020F0502020204030204" pitchFamily="34" charset="0"/>
+                <a:ea typeface="Calibri" panose="020F0502020204030204" pitchFamily="34" charset="-122"/>
+                <a:cs typeface="Calibri" panose="020F0502020204030204" pitchFamily="34" charset="-120"/>
+              </a:rPr>
+              <a:t>an</a:t>
+            </a:r>
+            <a:r>
+              <a:rPr lang="en-US" sz="1050" b="1" dirty="0">
+                <a:solidFill>
+                  <a:srgbClr val="0F766E"/>
+                </a:solidFill>
+                <a:latin typeface="Calibri" panose="020F0502020204030204" pitchFamily="34" charset="0"/>
+                <a:ea typeface="Calibri" panose="020F0502020204030204" pitchFamily="34" charset="-122"/>
+                <a:cs typeface="Calibri" panose="020F0502020204030204" pitchFamily="34" charset="-120"/>
+              </a:rPr>
+              <a:t>dl</a:t>
+            </a:r>
+            <a:r>
+              <a:rPr lang="de-DE" altLang="en-US" sz="1050" b="1" dirty="0">
+                <a:solidFill>
+                  <a:srgbClr val="0F766E"/>
+                </a:solidFill>
+                <a:latin typeface="Calibri" panose="020F0502020204030204" pitchFamily="34" charset="0"/>
+                <a:ea typeface="Calibri" panose="020F0502020204030204" pitchFamily="34" charset="-122"/>
+                <a:cs typeface="Calibri" panose="020F0502020204030204" pitchFamily="34" charset="-120"/>
+              </a:rPr>
+              <a:t>ing</a:t>
+            </a:r>
+            <a:endParaRPr lang="de-DE" altLang="en-US" sz="1050" b="1" dirty="0">
+              <a:solidFill>
+                <a:srgbClr val="0F766E"/>
+              </a:solidFill>
+              <a:latin typeface="Calibri" panose="020F0502020204030204" pitchFamily="34" charset="0"/>
+              <a:ea typeface="Calibri" panose="020F0502020204030204" pitchFamily="34" charset="-122"/>
+              <a:cs typeface="Calibri" panose="020F0502020204030204" pitchFamily="34" charset="-120"/>
+            </a:endParaRPr>
           </a:p>
         </p:txBody>
       </p:sp>
@@ -6155,9 +6311,49 @@
                 <a:ea typeface="Calibri" panose="020F0502020204030204" pitchFamily="34" charset="-122"/>
                 <a:cs typeface="Calibri" panose="020F0502020204030204" pitchFamily="34" charset="-120"/>
               </a:rPr>
-              <a:t>intermediate_steps captured for eval</a:t>
-            </a:r>
-            <a:endParaRPr lang="en-US" sz="1050" dirty="0"/>
+              <a:t>intermediate_steps captured for </a:t>
+            </a:r>
+            <a:r>
+              <a:rPr lang="de-DE" altLang="en-US" sz="1050" dirty="0">
+                <a:solidFill>
+                  <a:srgbClr val="334155"/>
+                </a:solidFill>
+                <a:latin typeface="Calibri" panose="020F0502020204030204" pitchFamily="34" charset="0"/>
+                <a:ea typeface="Calibri" panose="020F0502020204030204" pitchFamily="34" charset="-122"/>
+                <a:cs typeface="Calibri" panose="020F0502020204030204" pitchFamily="34" charset="-120"/>
+              </a:rPr>
+              <a:t>embedded video display and </a:t>
+            </a:r>
+            <a:r>
+              <a:rPr lang="en-US" sz="1050" dirty="0">
+                <a:solidFill>
+                  <a:srgbClr val="334155"/>
+                </a:solidFill>
+                <a:latin typeface="Calibri" panose="020F0502020204030204" pitchFamily="34" charset="0"/>
+                <a:ea typeface="Calibri" panose="020F0502020204030204" pitchFamily="34" charset="-122"/>
+                <a:cs typeface="Calibri" panose="020F0502020204030204" pitchFamily="34" charset="-120"/>
+              </a:rPr>
+              <a:t>eval</a:t>
+            </a:r>
+            <a:r>
+              <a:rPr lang="de-DE" altLang="en-US" sz="1050" dirty="0">
+                <a:solidFill>
+                  <a:srgbClr val="334155"/>
+                </a:solidFill>
+                <a:latin typeface="Calibri" panose="020F0502020204030204" pitchFamily="34" charset="0"/>
+                <a:ea typeface="Calibri" panose="020F0502020204030204" pitchFamily="34" charset="-122"/>
+                <a:cs typeface="Calibri" panose="020F0502020204030204" pitchFamily="34" charset="-120"/>
+              </a:rPr>
+              <a:t>uation</a:t>
+            </a:r>
+            <a:endParaRPr lang="de-DE" altLang="en-US" sz="1050" dirty="0">
+              <a:solidFill>
+                <a:srgbClr val="334155"/>
+              </a:solidFill>
+              <a:latin typeface="Calibri" panose="020F0502020204030204" pitchFamily="34" charset="0"/>
+              <a:ea typeface="Calibri" panose="020F0502020204030204" pitchFamily="34" charset="-122"/>
+              <a:cs typeface="Calibri" panose="020F0502020204030204" pitchFamily="34" charset="-120"/>
+            </a:endParaRPr>
           </a:p>
         </p:txBody>
       </p:sp>
@@ -7478,13 +7674,14 @@
               <a:t>Pinecone:  index=test-index  |  dim=1536  |  metric=</a:t>
             </a:r>
             <a:r>
-              <a:rPr lang="de-DE" altLang="en-US" sz="900" dirty="0">
+              <a:rPr lang="en-US" sz="900" dirty="0">
                 <a:solidFill>
                   <a:srgbClr val="64748B"/>
                 </a:solidFill>
-                <a:latin typeface="Calibri" panose="020F0502020204030204" pitchFamily="34" charset="0"/>
+                <a:latin typeface="Courier New" panose="02070309020205020404" pitchFamily="34" charset="0"/>
                 <a:ea typeface="Courier New" panose="02070309020205020404" pitchFamily="34" charset="-122"/>
                 <a:cs typeface="Courier New" panose="02070309020205020404" pitchFamily="34" charset="-120"/>
+                <a:sym typeface="+mn-ea"/>
               </a:rPr>
               <a:t>cosine</a:t>
             </a:r>
@@ -7830,6 +8027,12 @@
             <a:prstDash val="solid"/>
           </a:ln>
         </p:spPr>
+        <p:txBody>
+          <a:bodyPr/>
+          <a:p>
+            <a:endParaRPr lang="en-US"/>
+          </a:p>
+        </p:txBody>
       </p:sp>
       <p:sp>
         <p:nvSpPr>
@@ -7901,7 +8104,7 @@
                 <a:ea typeface="Calibri" panose="020F0502020204030204" pitchFamily="34" charset="-122"/>
                 <a:cs typeface="Calibri" panose="020F0502020204030204" pitchFamily="34" charset="-120"/>
               </a:rPr>
-              <a:t>"rag-agent-tests" (3 examples)</a:t>
+              <a:t>"rag-agent-tests"</a:t>
             </a:r>
             <a:endParaRPr lang="en-US" sz="1000" dirty="0"/>
           </a:p>
@@ -11161,7 +11364,29 @@
                 <a:ea typeface="Calibri" panose="020F0502020204030204" pitchFamily="34" charset="-122"/>
                 <a:cs typeface="Calibri" panose="020F0502020204030204" pitchFamily="34" charset="-120"/>
               </a:rPr>
-              <a:t>⚡  Backup: screenshots ready in case of Pinecone / OpenAI API connectivity issues</a:t>
+              <a:t>⚡  Backup: </a:t>
+            </a:r>
+            <a:r>
+              <a:rPr lang="de-DE" altLang="en-US" sz="950" dirty="0">
+                <a:solidFill>
+                  <a:srgbClr val="64748B"/>
+                </a:solidFill>
+                <a:latin typeface="Calibri" panose="020F0502020204030204" pitchFamily="34" charset="0"/>
+                <a:ea typeface="Calibri" panose="020F0502020204030204" pitchFamily="34" charset="-122"/>
+                <a:cs typeface="Calibri" panose="020F0502020204030204" pitchFamily="34" charset="-120"/>
+              </a:rPr>
+              <a:t>video </a:t>
+            </a:r>
+            <a:r>
+              <a:rPr lang="en-US" sz="950" dirty="0">
+                <a:solidFill>
+                  <a:srgbClr val="64748B"/>
+                </a:solidFill>
+                <a:latin typeface="Calibri" panose="020F0502020204030204" pitchFamily="34" charset="0"/>
+                <a:ea typeface="Calibri" panose="020F0502020204030204" pitchFamily="34" charset="-122"/>
+                <a:cs typeface="Calibri" panose="020F0502020204030204" pitchFamily="34" charset="-120"/>
+              </a:rPr>
+              <a:t>ready in case of Pinecone / OpenAI API connectivity issues</a:t>
             </a:r>
             <a:endParaRPr lang="en-US" sz="950" dirty="0"/>
           </a:p>

</xml_diff>